<commit_message>
Added some missed statements
</commit_message>
<xml_diff>
--- a/PokeStudy_Presentation - Team Stack Underflow - Sagar, Yuxuan, Aditya.pptx
+++ b/PokeStudy_Presentation - Team Stack Underflow - Sagar, Yuxuan, Aditya.pptx
@@ -122,6 +122,11 @@
       </a:defRPr>
     </a:lvl9pPr>
   </p:defaultTextStyle>
+  <p:extLst>
+    <p:ext uri="{EFAFB233-063F-42B5-8137-9DF3F51BA10A}">
+      <p15:sldGuideLst xmlns:p15="http://schemas.microsoft.com/office/powerpoint/2012/main"/>
+    </p:ext>
+  </p:extLst>
 </p:presentation>
 </file>
 
@@ -226,7 +231,7 @@
           </a:lstStyle>
           <a:p>
             <a:fld id="{DD92FA23-3BBA-4359-B914-E94E09CD2044}" type="datetimeFigureOut">
-              <a:t>4/13/2026</a:t>
+              <a:t>4/14/2026</a:t>
             </a:fld>
             <a:endParaRPr lang="en-US"/>
           </a:p>
@@ -3809,7 +3814,7 @@
         </p:nvSpPr>
         <p:spPr>
           <a:xfrm>
-            <a:off x="457200" y="3005705"/>
+            <a:off x="457200" y="3013139"/>
             <a:ext cx="3840480" cy="1828800"/>
           </a:xfrm>
           <a:prstGeom prst="roundRect">
@@ -3878,7 +3883,7 @@
         </p:nvSpPr>
         <p:spPr>
           <a:xfrm>
-            <a:off x="731520" y="3667110"/>
+            <a:off x="731520" y="3521564"/>
             <a:ext cx="3383280" cy="320040"/>
           </a:xfrm>
           <a:prstGeom prst="rect">
@@ -3895,10 +3900,10 @@
               <a:buNone/>
             </a:pPr>
             <a:r>
-              <a:rPr lang="en-US" sz="1100"/>
+              <a:rPr lang="en-US" sz="1100" dirty="0"/>
               <a:t>✓ Daily study streak counter</a:t>
             </a:r>
-            <a:endParaRPr lang="en-US" sz="1100">
+            <a:endParaRPr lang="en-US" sz="1100" dirty="0">
               <a:ea typeface="Calibri"/>
               <a:cs typeface="Calibri"/>
             </a:endParaRPr>
@@ -3913,27 +3918,36 @@
         </p:nvSpPr>
         <p:spPr>
           <a:xfrm>
-            <a:off x="731520" y="4035906"/>
-            <a:ext cx="3383280" cy="320040"/>
-          </a:xfrm>
-          <a:prstGeom prst="rect">
-            <a:avLst/>
-          </a:prstGeom>
-          <a:noFill/>
-          <a:ln/>
-        </p:spPr>
-        <p:txBody>
-          <a:bodyPr wrap="square" lIns="91440" tIns="45720" rIns="91440" bIns="45720" rtlCol="0" anchor="ctr"/>
+            <a:off x="731520" y="3841604"/>
+            <a:ext cx="3383280" cy="514342"/>
+          </a:xfrm>
+          <a:prstGeom prst="rect">
+            <a:avLst/>
+          </a:prstGeom>
+          <a:noFill/>
+          <a:ln/>
+        </p:spPr>
+        <p:txBody>
+          <a:bodyPr wrap="square" lIns="91440" tIns="45720" rIns="91440" bIns="45720" rtlCol="0" anchor="t"/>
           <a:lstStyle/>
           <a:p>
             <a:pPr marL="0" indent="0">
               <a:buNone/>
             </a:pPr>
             <a:r>
-              <a:rPr lang="en-US" sz="1100"/>
-              <a:t>✓ Global &amp; room leaderboards</a:t>
-            </a:r>
-            <a:endParaRPr lang="en-US" sz="1100">
+              <a:rPr lang="en-US" sz="1100" dirty="0"/>
+              <a:t>✓ Global &amp; room leaderboards. Sorted based on Trophy count. In case there is a tie between users, studied time is compared to rank the users.</a:t>
+            </a:r>
+          </a:p>
+          <a:p>
+            <a:pPr marL="0" indent="0">
+              <a:buNone/>
+            </a:pPr>
+            <a:r>
+              <a:rPr lang="en-US" sz="1100" dirty="0"/>
+              <a:t>  </a:t>
+            </a:r>
+            <a:endParaRPr lang="en-US" sz="1100" dirty="0">
               <a:ea typeface="Calibri"/>
               <a:cs typeface="Calibri"/>
             </a:endParaRPr>
@@ -3948,7 +3962,7 @@
         </p:nvSpPr>
         <p:spPr>
           <a:xfrm>
-            <a:off x="731520" y="4357789"/>
+            <a:off x="731520" y="4402393"/>
             <a:ext cx="3383280" cy="320040"/>
           </a:xfrm>
           <a:prstGeom prst="rect">
@@ -3965,10 +3979,10 @@
               <a:buNone/>
             </a:pPr>
             <a:r>
-              <a:rPr lang="en-US" sz="1100"/>
+              <a:rPr lang="en-US" sz="1100" dirty="0"/>
               <a:t>✓ Action history with timestamps</a:t>
             </a:r>
-            <a:endParaRPr lang="en-US" sz="1100">
+            <a:endParaRPr lang="en-US" sz="1100" dirty="0">
               <a:ea typeface="Calibri"/>
               <a:cs typeface="Calibri"/>
             </a:endParaRPr>
@@ -4965,14 +4979,30 @@
               <a:buNone/>
             </a:pPr>
             <a:r>
-              <a:rPr lang="en-US" sz="1200">
+              <a:rPr lang="en-US" sz="1200" dirty="0">
                 <a:solidFill>
                   <a:srgbClr val="212121"/>
                 </a:solidFill>
               </a:rPr>
-              <a:t>View global rankings, check Pokemon collection, study streak</a:t>
-            </a:r>
-            <a:endParaRPr lang="en-US" sz="1200"/>
+              <a:t>View global rankings, check </a:t>
+            </a:r>
+            <a:r>
+              <a:rPr lang="en-US" sz="1200" dirty="0" err="1">
+                <a:solidFill>
+                  <a:srgbClr val="212121"/>
+                </a:solidFill>
+              </a:rPr>
+              <a:t>Pokemon</a:t>
+            </a:r>
+            <a:r>
+              <a:rPr lang="en-US" sz="1200" dirty="0">
+                <a:solidFill>
+                  <a:srgbClr val="212121"/>
+                </a:solidFill>
+              </a:rPr>
+              <a:t> collection, study streak</a:t>
+            </a:r>
+            <a:endParaRPr lang="en-US" sz="1200" dirty="0"/>
           </a:p>
         </p:txBody>
       </p:sp>
@@ -12322,7 +12352,7 @@
         <p:spPr>
           <a:xfrm>
             <a:off x="640080" y="3839442"/>
-            <a:ext cx="7863840" cy="943908"/>
+            <a:ext cx="7863840" cy="1148870"/>
           </a:xfrm>
           <a:prstGeom prst="rect">
             <a:avLst/>
@@ -12339,14 +12369,14 @@
               <a:buChar char="ü"/>
             </a:pPr>
             <a:r>
-              <a:rPr lang="en-US" sz="1000" b="1">
+              <a:rPr lang="en-US" sz="1000" b="1" dirty="0">
                 <a:solidFill>
                   <a:srgbClr val="212121"/>
                 </a:solidFill>
               </a:rPr>
               <a:t>Service layer handles ALL business logic except Leadership Controller</a:t>
             </a:r>
-            <a:endParaRPr lang="en-US" b="1">
+            <a:endParaRPr lang="en-US" b="1" dirty="0">
               <a:ea typeface="Calibri"/>
               <a:cs typeface="Calibri"/>
             </a:endParaRPr>
@@ -12357,7 +12387,7 @@
               <a:buChar char="ü"/>
             </a:pPr>
             <a:r>
-              <a:rPr lang="en-US" sz="1000" b="1">
+              <a:rPr lang="en-US" sz="1000" b="1" dirty="0">
                 <a:solidFill>
                   <a:srgbClr val="212121"/>
                 </a:solidFill>
@@ -12373,7 +12403,7 @@
               <a:buChar char="ü"/>
             </a:pPr>
             <a:r>
-              <a:rPr lang="en-US" sz="1000" b="1">
+              <a:rPr lang="en-US" sz="1000" b="1" dirty="0">
                 <a:solidFill>
                   <a:srgbClr val="212121"/>
                 </a:solidFill>
@@ -12383,7 +12413,7 @@
               <a:t>Only 1 FXML file with controller: </a:t>
             </a:r>
             <a:r>
-              <a:rPr lang="en-US" sz="1000" b="1" err="1">
+              <a:rPr lang="en-US" sz="1000" b="1" dirty="0" err="1">
                 <a:solidFill>
                   <a:srgbClr val="212121"/>
                 </a:solidFill>
@@ -12393,7 +12423,7 @@
               <a:t>LeaderboardView.fxml</a:t>
             </a:r>
             <a:r>
-              <a:rPr lang="en-US" sz="1000" b="1">
+              <a:rPr lang="en-US" sz="1000" b="1" dirty="0">
                 <a:solidFill>
                   <a:srgbClr val="212121"/>
                 </a:solidFill>
@@ -12403,7 +12433,7 @@
               <a:t> + </a:t>
             </a:r>
             <a:r>
-              <a:rPr lang="en-US" sz="1000" b="1" err="1">
+              <a:rPr lang="en-US" sz="1000" b="1" dirty="0" err="1">
                 <a:solidFill>
                   <a:srgbClr val="212121"/>
                 </a:solidFill>
@@ -12412,7 +12442,7 @@
               </a:rPr>
               <a:t>LeaderboardController</a:t>
             </a:r>
-            <a:endParaRPr lang="en-US" sz="1000" b="1">
+            <a:endParaRPr lang="en-US" sz="1000" b="1" dirty="0">
               <a:solidFill>
                 <a:srgbClr val="212121"/>
               </a:solidFill>
@@ -12426,7 +12456,7 @@
               <a:buChar char="ü"/>
             </a:pPr>
             <a:r>
-              <a:rPr lang="en-US" sz="1000" b="1">
+              <a:rPr lang="en-US" sz="1000" b="1" dirty="0">
                 <a:solidFill>
                   <a:srgbClr val="212121"/>
                 </a:solidFill>
@@ -12442,7 +12472,7 @@
               <a:buChar char="ü"/>
             </a:pPr>
             <a:r>
-              <a:rPr lang="en-US" sz="1000" b="1">
+              <a:rPr lang="en-US" sz="1000" b="1" dirty="0">
                 <a:solidFill>
                   <a:srgbClr val="212121"/>
                 </a:solidFill>
@@ -12458,7 +12488,7 @@
               <a:buChar char="ü"/>
             </a:pPr>
             <a:r>
-              <a:rPr lang="en-US" sz="1000" b="1">
+              <a:rPr lang="en-US" sz="1000" b="1" dirty="0">
                 <a:solidFill>
                   <a:srgbClr val="212121"/>
                 </a:solidFill>
@@ -12469,7 +12499,23 @@
             </a:r>
           </a:p>
           <a:p>
-            <a:endParaRPr lang="en-US" sz="1000">
+            <a:pPr marL="171450" indent="-171450">
+              <a:buFont typeface="Wingdings"/>
+              <a:buChar char="ü"/>
+            </a:pPr>
+            <a:r>
+              <a:rPr lang="en-US" sz="1000" b="1" dirty="0">
+                <a:solidFill>
+                  <a:srgbClr val="212121"/>
+                </a:solidFill>
+                <a:ea typeface="Calibri"/>
+                <a:cs typeface="Calibri"/>
+              </a:rPr>
+              <a:t>Leaderboard is sorted based on Trophy count. In case there is a tie between users, studied time is compared to rank the users.</a:t>
+            </a:r>
+          </a:p>
+          <a:p>
+            <a:endParaRPr lang="en-US" sz="1000" dirty="0">
               <a:solidFill>
                 <a:srgbClr val="212121"/>
               </a:solidFill>
@@ -12478,7 +12524,7 @@
             </a:endParaRPr>
           </a:p>
           <a:p>
-            <a:endParaRPr lang="en-US" sz="1000">
+            <a:endParaRPr lang="en-US" sz="1000" dirty="0">
               <a:solidFill>
                 <a:srgbClr val="212121"/>
               </a:solidFill>

</xml_diff>